<commit_message>
Fix break-slide image z-order (shadow behind) and reduce cover title size
</commit_message>
<xml_diff>
--- a/content/the-human-edge-deck.pptx
+++ b/content/the-human-edge-deck.pptx
@@ -3287,8 +3287,8 @@
         </p:nvSpPr>
         <p:spPr>
           <a:xfrm>
-            <a:off x="868680" y="2194560"/>
-            <a:ext cx="10424160" cy="3840480"/>
+            <a:off x="868680" y="2011680"/>
+            <a:ext cx="10424160" cy="4023360"/>
           </a:xfrm>
           <a:prstGeom prst="rect">
             <a:avLst/>
@@ -3303,11 +3303,11 @@
           <a:p>
             <a:pPr algn="l">
               <a:lnSpc>
-                <a:spcPct val="86000"/>
+                <a:spcPct val="88000"/>
               </a:lnSpc>
             </a:pPr>
             <a:r>
-              <a:rPr sz="15000" b="0" i="0">
+              <a:rPr sz="11800" b="0" i="0">
                 <a:solidFill>
                   <a:srgbClr val="181613"/>
                 </a:solidFill>
@@ -3320,11 +3320,11 @@
           <a:p>
             <a:pPr algn="l">
               <a:lnSpc>
-                <a:spcPct val="86000"/>
+                <a:spcPct val="88000"/>
               </a:lnSpc>
             </a:pPr>
             <a:r>
-              <a:rPr sz="15000" b="0" i="0">
+              <a:rPr sz="11800" b="0" i="0">
                 <a:solidFill>
                   <a:srgbClr val="181613"/>
                 </a:solidFill>
@@ -3337,11 +3337,11 @@
           <a:p>
             <a:pPr algn="l">
               <a:lnSpc>
-                <a:spcPct val="86000"/>
+                <a:spcPct val="88000"/>
               </a:lnSpc>
             </a:pPr>
             <a:r>
-              <a:rPr sz="15000" b="0" i="0">
+              <a:rPr sz="11800" b="0" i="0">
                 <a:solidFill>
                   <a:srgbClr val="181613"/>
                 </a:solidFill>
@@ -3360,7 +3360,7 @@
         </p:nvSpPr>
         <p:spPr>
           <a:xfrm>
-            <a:off x="868680" y="5943600"/>
+            <a:off x="868680" y="6080760"/>
             <a:ext cx="10424160" cy="457200"/>
           </a:xfrm>
           <a:prstGeom prst="rect">
@@ -4845,45 +4845,15 @@
           </a:p>
         </p:txBody>
       </p:sp>
-      <p:pic>
-        <p:nvPicPr>
-          <p:cNvPr id="3" name="Picture 2" descr="break-morning-tea.jpg"/>
-          <p:cNvPicPr>
-            <a:picLocks noChangeAspect="1"/>
-          </p:cNvPicPr>
-          <p:nvPr/>
-        </p:nvPicPr>
-        <p:blipFill>
-          <a:blip r:embed="rId2"/>
-          <a:stretch>
-            <a:fillRect/>
-          </a:stretch>
-        </p:blipFill>
-        <p:spPr>
-          <a:xfrm>
-            <a:off x="4541367" y="1554480"/>
-            <a:ext cx="3108960" cy="2286000"/>
-          </a:xfrm>
-          <a:prstGeom prst="rect">
-            <a:avLst/>
-          </a:prstGeom>
-          <a:ln w="22225">
-            <a:solidFill>
-              <a:srgbClr val="181613"/>
-            </a:solidFill>
-          </a:ln>
-          <a:effectLst/>
-        </p:spPr>
-      </p:pic>
-      <p:sp>
-        <p:nvSpPr>
-          <p:cNvPr id="4" name="Rectangle 3"/>
+      <p:sp>
+        <p:nvSpPr>
+          <p:cNvPr id="3" name="Rectangle 2"/>
           <p:cNvSpPr/>
           <p:nvPr/>
         </p:nvSpPr>
         <p:spPr>
           <a:xfrm>
-            <a:off x="4541367" y="1664207"/>
+            <a:off x="4541367" y="1682495"/>
             <a:ext cx="3108960" cy="2286000"/>
           </a:xfrm>
           <a:prstGeom prst="rect">
@@ -4919,6 +4889,36 @@
           </a:p>
         </p:txBody>
       </p:sp>
+      <p:pic>
+        <p:nvPicPr>
+          <p:cNvPr id="4" name="Picture 3" descr="break-morning-tea.jpg"/>
+          <p:cNvPicPr>
+            <a:picLocks noChangeAspect="1"/>
+          </p:cNvPicPr>
+          <p:nvPr/>
+        </p:nvPicPr>
+        <p:blipFill>
+          <a:blip r:embed="rId2"/>
+          <a:stretch>
+            <a:fillRect/>
+          </a:stretch>
+        </p:blipFill>
+        <p:spPr>
+          <a:xfrm>
+            <a:off x="4541367" y="1554480"/>
+            <a:ext cx="3108960" cy="2286000"/>
+          </a:xfrm>
+          <a:prstGeom prst="rect">
+            <a:avLst/>
+          </a:prstGeom>
+          <a:ln w="22225">
+            <a:solidFill>
+              <a:srgbClr val="181613"/>
+            </a:solidFill>
+          </a:ln>
+          <a:effectLst/>
+        </p:spPr>
+      </p:pic>
       <p:sp>
         <p:nvSpPr>
           <p:cNvPr id="5" name="TextBox 4"/>
@@ -8722,45 +8722,15 @@
           </a:p>
         </p:txBody>
       </p:sp>
-      <p:pic>
-        <p:nvPicPr>
-          <p:cNvPr id="3" name="Picture 2" descr="break-lunch.jpg"/>
-          <p:cNvPicPr>
-            <a:picLocks noChangeAspect="1"/>
-          </p:cNvPicPr>
-          <p:nvPr/>
-        </p:nvPicPr>
-        <p:blipFill>
-          <a:blip r:embed="rId2"/>
-          <a:stretch>
-            <a:fillRect/>
-          </a:stretch>
-        </p:blipFill>
-        <p:spPr>
-          <a:xfrm>
-            <a:off x="4541367" y="1554480"/>
-            <a:ext cx="3108960" cy="2286000"/>
-          </a:xfrm>
-          <a:prstGeom prst="rect">
-            <a:avLst/>
-          </a:prstGeom>
-          <a:ln w="22225">
-            <a:solidFill>
-              <a:srgbClr val="181613"/>
-            </a:solidFill>
-          </a:ln>
-          <a:effectLst/>
-        </p:spPr>
-      </p:pic>
-      <p:sp>
-        <p:nvSpPr>
-          <p:cNvPr id="4" name="Rectangle 3"/>
+      <p:sp>
+        <p:nvSpPr>
+          <p:cNvPr id="3" name="Rectangle 2"/>
           <p:cNvSpPr/>
           <p:nvPr/>
         </p:nvSpPr>
         <p:spPr>
           <a:xfrm>
-            <a:off x="4541367" y="1664207"/>
+            <a:off x="4541367" y="1682495"/>
             <a:ext cx="3108960" cy="2286000"/>
           </a:xfrm>
           <a:prstGeom prst="rect">
@@ -8796,6 +8766,36 @@
           </a:p>
         </p:txBody>
       </p:sp>
+      <p:pic>
+        <p:nvPicPr>
+          <p:cNvPr id="4" name="Picture 3" descr="break-lunch.jpg"/>
+          <p:cNvPicPr>
+            <a:picLocks noChangeAspect="1"/>
+          </p:cNvPicPr>
+          <p:nvPr/>
+        </p:nvPicPr>
+        <p:blipFill>
+          <a:blip r:embed="rId2"/>
+          <a:stretch>
+            <a:fillRect/>
+          </a:stretch>
+        </p:blipFill>
+        <p:spPr>
+          <a:xfrm>
+            <a:off x="4541367" y="1554480"/>
+            <a:ext cx="3108960" cy="2286000"/>
+          </a:xfrm>
+          <a:prstGeom prst="rect">
+            <a:avLst/>
+          </a:prstGeom>
+          <a:ln w="22225">
+            <a:solidFill>
+              <a:srgbClr val="181613"/>
+            </a:solidFill>
+          </a:ln>
+          <a:effectLst/>
+        </p:spPr>
+      </p:pic>
       <p:sp>
         <p:nvSpPr>
           <p:cNvPr id="5" name="TextBox 4"/>
@@ -9659,45 +9659,15 @@
           </a:p>
         </p:txBody>
       </p:sp>
-      <p:pic>
-        <p:nvPicPr>
-          <p:cNvPr id="3" name="Picture 2" descr="break-afternoon-tea.jpg"/>
-          <p:cNvPicPr>
-            <a:picLocks noChangeAspect="1"/>
-          </p:cNvPicPr>
-          <p:nvPr/>
-        </p:nvPicPr>
-        <p:blipFill>
-          <a:blip r:embed="rId2"/>
-          <a:stretch>
-            <a:fillRect/>
-          </a:stretch>
-        </p:blipFill>
-        <p:spPr>
-          <a:xfrm>
-            <a:off x="4541367" y="1554480"/>
-            <a:ext cx="3108960" cy="2286000"/>
-          </a:xfrm>
-          <a:prstGeom prst="rect">
-            <a:avLst/>
-          </a:prstGeom>
-          <a:ln w="22225">
-            <a:solidFill>
-              <a:srgbClr val="181613"/>
-            </a:solidFill>
-          </a:ln>
-          <a:effectLst/>
-        </p:spPr>
-      </p:pic>
-      <p:sp>
-        <p:nvSpPr>
-          <p:cNvPr id="4" name="Rectangle 3"/>
+      <p:sp>
+        <p:nvSpPr>
+          <p:cNvPr id="3" name="Rectangle 2"/>
           <p:cNvSpPr/>
           <p:nvPr/>
         </p:nvSpPr>
         <p:spPr>
           <a:xfrm>
-            <a:off x="4541367" y="1664207"/>
+            <a:off x="4541367" y="1682495"/>
             <a:ext cx="3108960" cy="2286000"/>
           </a:xfrm>
           <a:prstGeom prst="rect">
@@ -9733,6 +9703,36 @@
           </a:p>
         </p:txBody>
       </p:sp>
+      <p:pic>
+        <p:nvPicPr>
+          <p:cNvPr id="4" name="Picture 3" descr="break-afternoon-tea.jpg"/>
+          <p:cNvPicPr>
+            <a:picLocks noChangeAspect="1"/>
+          </p:cNvPicPr>
+          <p:nvPr/>
+        </p:nvPicPr>
+        <p:blipFill>
+          <a:blip r:embed="rId2"/>
+          <a:stretch>
+            <a:fillRect/>
+          </a:stretch>
+        </p:blipFill>
+        <p:spPr>
+          <a:xfrm>
+            <a:off x="4541367" y="1554480"/>
+            <a:ext cx="3108960" cy="2286000"/>
+          </a:xfrm>
+          <a:prstGeom prst="rect">
+            <a:avLst/>
+          </a:prstGeom>
+          <a:ln w="22225">
+            <a:solidFill>
+              <a:srgbClr val="181613"/>
+            </a:solidFill>
+          </a:ln>
+          <a:effectLst/>
+        </p:spPr>
+      </p:pic>
       <p:sp>
         <p:nvSpPr>
           <p:cNvPr id="5" name="TextBox 4"/>

</xml_diff>